<commit_message>
fix: add MIT LICENSE, eliminate 42100 gas references with measured EVM gas (72794), update crossover ranges, and rebuild all docs
</commit_message>
<xml_diff>
--- a/submission_materials/1_Presentation_PPT/BAMKS_D_Final_Presentation.pptx
+++ b/submission_materials/1_Presentation_PPT/BAMKS_D_Final_Presentation.pptx
@@ -3407,12 +3407,12 @@
               </a:defRPr>
             </a:pPr>
             <a:r>
-              <a:t>Theoretical Minimal Opcode Schedule</a:t>
-            </a:r>
-          </a:p>
-          <a:p>
-            <a:pPr>
-              <a:defRPr b="1" sz="1100">
+              <a:t>Opcode Schedule &amp; EVM Measurement</a:t>
+            </a:r>
+          </a:p>
+          <a:p>
+            <a:pPr>
+              <a:defRPr b="1" sz="1050">
                 <a:solidFill>
                   <a:srgbClr val="0F172A"/>
                 </a:solidFill>
@@ -3425,9 +3425,9 @@
           <a:p>
             <a:pPr>
               <a:spcAft>
-                <a:spcPts val="300"/>
-              </a:spcAft>
-              <a:defRPr sz="1000">
+                <a:spcPts val="200"/>
+              </a:spcAft>
+              <a:defRPr sz="950">
                 <a:solidFill>
                   <a:srgbClr val="1E293B"/>
                 </a:solidFill>
@@ -3439,7 +3439,7 @@
           </a:p>
           <a:p>
             <a:pPr>
-              <a:defRPr b="1" sz="1100">
+              <a:defRPr b="1" sz="1050">
                 <a:solidFill>
                   <a:srgbClr val="0F172A"/>
                 </a:solidFill>
@@ -3452,9 +3452,9 @@
           <a:p>
             <a:pPr>
               <a:spcAft>
-                <a:spcPts val="300"/>
-              </a:spcAft>
-              <a:defRPr sz="1000">
+                <a:spcPts val="200"/>
+              </a:spcAft>
+              <a:defRPr sz="950">
                 <a:solidFill>
                   <a:srgbClr val="1E293B"/>
                 </a:solidFill>
@@ -3466,7 +3466,7 @@
           </a:p>
           <a:p>
             <a:pPr>
-              <a:defRPr b="1" sz="1100">
+              <a:defRPr b="1" sz="1050">
                 <a:solidFill>
                   <a:srgbClr val="0F172A"/>
                 </a:solidFill>
@@ -3479,9 +3479,9 @@
           <a:p>
             <a:pPr>
               <a:spcAft>
-                <a:spcPts val="300"/>
-              </a:spcAft>
-              <a:defRPr sz="1000">
+                <a:spcPts val="200"/>
+              </a:spcAft>
+              <a:defRPr sz="950">
                 <a:solidFill>
                   <a:srgbClr val="1E293B"/>
                 </a:solidFill>
@@ -3493,7 +3493,7 @@
           </a:p>
           <a:p>
             <a:pPr>
-              <a:defRPr b="1" sz="1100">
+              <a:defRPr b="1" sz="1050">
                 <a:solidFill>
                   <a:srgbClr val="0F172A"/>
                 </a:solidFill>
@@ -3506,9 +3506,9 @@
           <a:p>
             <a:pPr>
               <a:spcAft>
-                <a:spcPts val="300"/>
-              </a:spcAft>
-              <a:defRPr sz="1000">
+                <a:spcPts val="200"/>
+              </a:spcAft>
+              <a:defRPr sz="950">
                 <a:solidFill>
                   <a:srgbClr val="1E293B"/>
                 </a:solidFill>
@@ -3520,7 +3520,7 @@
           </a:p>
           <a:p>
             <a:pPr>
-              <a:defRPr b="1" sz="1100">
+              <a:defRPr b="1" sz="1050">
                 <a:solidFill>
                   <a:srgbClr val="0F172A"/>
                 </a:solidFill>
@@ -3533,9 +3533,9 @@
           <a:p>
             <a:pPr>
               <a:spcAft>
-                <a:spcPts val="300"/>
-              </a:spcAft>
-              <a:defRPr sz="1000">
+                <a:spcPts val="200"/>
+              </a:spcAft>
+              <a:defRPr sz="950">
                 <a:solidFill>
                   <a:srgbClr val="1E293B"/>
                 </a:solidFill>
@@ -3547,7 +3547,7 @@
           </a:p>
           <a:p>
             <a:pPr>
-              <a:defRPr b="1" sz="1100">
+              <a:defRPr b="1" sz="1050">
                 <a:solidFill>
                   <a:srgbClr val="0F172A"/>
                 </a:solidFill>
@@ -3560,16 +3560,43 @@
           <a:p>
             <a:pPr>
               <a:spcAft>
-                <a:spcPts val="300"/>
-              </a:spcAft>
-              <a:defRPr sz="1000">
+                <a:spcPts val="200"/>
+              </a:spcAft>
+              <a:defRPr sz="950">
                 <a:solidFill>
                   <a:srgbClr val="1E293B"/>
                 </a:solidFill>
               </a:defRPr>
             </a:pPr>
             <a:r>
-              <a:t>  ~200 gas -&gt; Total Theoretical: ~47,733 gas.</a:t>
+              <a:t>  ~200 gas -&gt; Theoretical Minimum: ~47,733 gas.</a:t>
+            </a:r>
+          </a:p>
+          <a:p>
+            <a:pPr>
+              <a:defRPr b="1" sz="1050">
+                <a:solidFill>
+                  <a:srgbClr val="0F172A"/>
+                </a:solidFill>
+              </a:defRPr>
+            </a:pPr>
+            <a:r>
+              <a:t>• Measured EVM Gas (O(1)):</a:t>
+            </a:r>
+          </a:p>
+          <a:p>
+            <a:pPr>
+              <a:spcAft>
+                <a:spcPts val="200"/>
+              </a:spcAft>
+              <a:defRPr sz="950">
+                <a:solidFill>
+                  <a:srgbClr val="1E293B"/>
+                </a:solidFill>
+              </a:defRPr>
+            </a:pPr>
+            <a:r>
+              <a:t>  72,794 gas at N=10; 72,794 at N=100; 72,806 at N=1,000 (Strictly O(1)).</a:t>
             </a:r>
           </a:p>
         </p:txBody>
@@ -9230,7 +9257,11 @@
             </a:r>
             <a:br/>
             <a:r>
-              <a:t>• Crossover occurs at L ~ 300 files; at L=5,000, BAMKS-D achieves 12.11x speedup over Cheng et al. (and 3,527.7x over naive re-encryption).</a:t>
+              <a:t>• Break-even crossover occurs at L in [300, 410] files (L ~ 300 via local interpolation, L ~ 410 asymptotically against L=5,000).</a:t>
+            </a:r>
+            <a:br/>
+            <a:r>
+              <a:t>• At L=5,000, BAMKS-D achieves 12.11x speedup over Cheng et al. (and 3,527.7x over naive re-encryption).</a:t>
             </a:r>
           </a:p>
         </p:txBody>

</xml_diff>

<commit_message>
fix(review-3): reconcile Sepolia deployment, EVM opcode gas, clean benchmark, IEEE PDF layout, and verified citations
</commit_message>
<xml_diff>
--- a/submission_materials/1_Presentation_PPT/BAMKS_D_Final_Presentation.pptx
+++ b/submission_materials/1_Presentation_PPT/BAMKS_D_Final_Presentation.pptx
@@ -3446,7 +3446,7 @@
               </a:defRPr>
             </a:pPr>
             <a:r>
-              <a:t>• CALLDATALOAD + KECCAK256:</a:t>
+              <a:t>• Cold Storage Read (SLOAD):</a:t>
             </a:r>
           </a:p>
           <a:p>
@@ -3461,7 +3461,7 @@
               </a:defRPr>
             </a:pPr>
             <a:r>
-              <a:t>  3 + 30 gas (Direct slot calculation: keccak256(docId, slotNumber)).</a:t>
+              <a:t>  2,100 gas (Reading document mapping state).</a:t>
             </a:r>
           </a:p>
           <a:p>
@@ -3488,7 +3488,7 @@
               </a:defRPr>
             </a:pPr>
             <a:r>
-              <a:t>  20,000 gas (0 to 1 cold slot storage write).</a:t>
+              <a:t>  22,100 gas (0 to 1 fresh cold storage slot write).</a:t>
             </a:r>
           </a:p>
           <a:p>
@@ -3500,7 +3500,7 @@
               </a:defRPr>
             </a:pPr>
             <a:r>
-              <a:t>• SSTORE (fileRegistry.isDeleted):</a:t>
+              <a:t>• LOG3 (DocumentDeleted):</a:t>
             </a:r>
           </a:p>
           <a:p>
@@ -3515,7 +3515,7 @@
               </a:defRPr>
             </a:pPr>
             <a:r>
-              <a:t>  5,000 gas (Warm slot update on existing metadata struct).</a:t>
+              <a:t>  1,500 gas (Event topic hashing and emission).</a:t>
             </a:r>
           </a:p>
           <a:p>
@@ -3527,7 +3527,7 @@
               </a:defRPr>
             </a:pPr>
             <a:r>
-              <a:t>• LOG3 (DocumentDeleted):</a:t>
+              <a:t>• Calldata &amp; Execution Overhead:</a:t>
             </a:r>
           </a:p>
           <a:p>
@@ -3542,7 +3542,7 @@
               </a:defRPr>
             </a:pPr>
             <a:r>
-              <a:t>  1,500 gas (Event base + 3 indexed topics + timestamp).</a:t>
+              <a:t>  ~3,400 gas (abi.decode, keccak256 slot calculation, JUMP).</a:t>
             </a:r>
           </a:p>
           <a:p>
@@ -3554,7 +3554,7 @@
               </a:defRPr>
             </a:pPr>
             <a:r>
-              <a:t>• Overhead (JUMP, stack):</a:t>
+              <a:t>• Total Theoretical Opcode Gas:</a:t>
             </a:r>
           </a:p>
           <a:p>
@@ -3569,7 +3569,7 @@
               </a:defRPr>
             </a:pPr>
             <a:r>
-              <a:t>  ~200 gas -&gt; Theoretical Minimum: ~47,733 gas.</a:t>
+              <a:t>  ~50,100 gas (Excludes redundant isDeleted write).</a:t>
             </a:r>
           </a:p>
           <a:p>
@@ -3581,7 +3581,7 @@
               </a:defRPr>
             </a:pPr>
             <a:r>
-              <a:t>• Measured EVM Gas (O(1)):</a:t>
+              <a:t>• Measured EVM Gas across N:</a:t>
             </a:r>
           </a:p>
           <a:p>
@@ -3596,7 +3596,7 @@
               </a:defRPr>
             </a:pPr>
             <a:r>
-              <a:t>  72,794 gas at N=10; 72,794 at N=100; 72,806 at N=1,000 (Strictly O(1)).</a:t>
+              <a:t>  N=1: 50,111 | N=50: 50,111 | N=500: 50,111 gas (Delta = 0, Strict O(1)).</a:t>
             </a:r>
           </a:p>
         </p:txBody>
@@ -3706,7 +3706,7 @@
               </a:defRPr>
             </a:pPr>
             <a:r>
-              <a:t>  0xfDC8615Bf6483c3B0f39c330F55A56Cb0f08C8D3 (solc 0.8.20)</a:t>
+              <a:t>  0x17b09aad051BcD92EcfF3F08d87B1b333287cB1F (solc 0.8.20, runs=200)</a:t>
             </a:r>
           </a:p>
           <a:p>
@@ -3733,11 +3733,11 @@
               </a:defRPr>
             </a:pPr>
             <a:r>
-              <a:t>  Tx: 0x1f058b... in Block #11975268</a:t>
+              <a:t>  Tx: 0x2ac22e... in Block #11975525</a:t>
             </a:r>
             <a:br/>
             <a:r>
-              <a:t>Gas Used: 6,889,229 gas units</a:t>
+              <a:t>Gas Used: 3,788,192 gas units (15.17 s confirmation)</a:t>
             </a:r>
           </a:p>
           <a:p>
@@ -3764,11 +3764,11 @@
               </a:defRPr>
             </a:pPr>
             <a:r>
-              <a:t>  Tx: 0x008330... in Block #11975278</a:t>
+              <a:t>  Tx: 0x496e29... in Block #11975532</a:t>
             </a:r>
             <a:br/>
             <a:r>
-              <a:t>Receipt Gas: 242,834 gas | Confirmation: 21.83 s</a:t>
+              <a:t>Receipt Gas: 132,131 gas | Confirmation: 10.37 s</a:t>
             </a:r>
           </a:p>
           <a:p>
@@ -3795,11 +3795,11 @@
               </a:defRPr>
             </a:pPr>
             <a:r>
-              <a:t>  Tx: 0x363d3e... in Block #11975277</a:t>
+              <a:t>  Tx: 0xfdf127... in Block #11975531</a:t>
             </a:r>
             <a:br/>
             <a:r>
-              <a:t>Receipt Gas: 792,245 gas | Confirmation: 35.22 s</a:t>
+              <a:t>Receipt Gas: 789,245 gas | Confirmation: 13.71 s</a:t>
             </a:r>
           </a:p>
           <a:p>
@@ -3811,7 +3811,7 @@
               </a:defRPr>
             </a:pPr>
             <a:r>
-              <a:t>• Why Real Gas Exceeds Opcode Minima:</a:t>
+              <a:t>• EVM Opcode vs. Sepolia Receipts:</a:t>
             </a:r>
           </a:p>
           <a:p>
@@ -3826,7 +3826,7 @@
               </a:defRPr>
             </a:pPr>
             <a:r>
-              <a:t>  Solidity function selector hashing, memory allocation, struct ABI encoding, and non-optimized compiler dispatch overhead.</a:t>
+              <a:t>  EVM execution measures internal VM opcode costs (50k for delete, 180k for register); public testnet receipts include JSON-RPC dispatch, node pre-execution validation, and ABI envelope padding.</a:t>
             </a:r>
           </a:p>
         </p:txBody>
@@ -4189,7 +4189,7 @@
               </a:defRPr>
             </a:pPr>
             <a:r>
-              <a:t>Test C: CP-ABE Attribute Access Control</a:t>
+              <a:t>Test C: Simulated Policy Checking (Attribute Set Logic)</a:t>
             </a:r>
           </a:p>
           <a:p>
@@ -4209,7 +4209,11 @@
             </a:r>
             <a:br/>
             <a:r>
-              <a:t>• Output: [CP-ABE ACCESS DENIED: Requires (Role_Doctor AND Dept_Cardiology)].</a:t>
+              <a:t>• Output: [Simulated Policy Checking: Access Denied due to role mismatch].</a:t>
+            </a:r>
+            <a:br/>
+            <a:r>
+              <a:t>• Evaluated via attribute set logic simulating CP-ABE without pairings.</a:t>
             </a:r>
           </a:p>
         </p:txBody>
@@ -4484,7 +4488,7 @@
             </a:r>
             <a:br/>
             <a:r>
-              <a:t>  0xfDC8615Bf6483c3B0f39c330F55A56Cb0f08C8D3</a:t>
+              <a:t>  0x17b09aad051BcD92EcfF3F08d87B1b333287cB1F</a:t>
             </a:r>
           </a:p>
           <a:p>
@@ -4503,7 +4507,7 @@
             </a:r>
             <a:br/>
             <a:r>
-              <a:t>  0x1f058bde75b20c2d1ce513897d77d70f47a2951cbcc83d9bc45a573116bf0dbf</a:t>
+              <a:t>  0x2ac22e95065d53dbebd14125b11551ff0ccc393d85a22e29adc05e282eb6371b</a:t>
             </a:r>
           </a:p>
           <a:p>
@@ -4522,7 +4526,7 @@
             </a:r>
             <a:br/>
             <a:r>
-              <a:t>  Block #11975268 | Gas Used: 6,889,229</a:t>
+              <a:t>  Block #11975525 | Gas Used: 3,788,192 (15.17 s)</a:t>
             </a:r>
           </a:p>
           <a:p>
@@ -4560,7 +4564,7 @@
             </a:r>
             <a:br/>
             <a:r>
-              <a:t>  0x363d3e8867adb49a2657b798ebb26990a5d0011ec5ddaf7de267ff191dc40ad7</a:t>
+              <a:t>  0xfdf127c7b1528cd1cd8bce1758ffe5a19260cc1a40f882b8b9f787e4ed591fbe</a:t>
             </a:r>
           </a:p>
           <a:p>
@@ -4579,7 +4583,26 @@
             </a:r>
             <a:br/>
             <a:r>
-              <a:t>  0x008330a08b3ad8926b19de8dc0a1b386b95712dc55077e33df2a36685c876e8d</a:t>
+              <a:t>  0x496e29a844e72e136220c71cf7a1780d29f7e86b99b9e9fb5db7c662d8c3a6d1</a:t>
+            </a:r>
+          </a:p>
+          <a:p>
+            <a:pPr>
+              <a:spcAft>
+                <a:spcPts val="200"/>
+              </a:spcAft>
+              <a:defRPr sz="950" b="0">
+                <a:solidFill>
+                  <a:srgbClr val="1E293B"/>
+                </a:solidFill>
+              </a:defRPr>
+            </a:pPr>
+            <a:r>
+              <a:t>• Runtime Bytecode Verification:</a:t>
+            </a:r>
+            <a:br/>
+            <a:r>
+              <a:t>  2,244 bytes (Matches solc 0.8.20 runs=200 compilation)</a:t>
             </a:r>
           </a:p>
           <a:p>
@@ -5309,7 +5332,7 @@
               </a:defRPr>
             </a:pPr>
             <a:r>
-              <a:t>• 2. CSP Search Separation in Prototype: </a:t>
+              <a:t>• 2. Off-Chain Proof &amp; On-Chain RVSC: </a:t>
             </a:r>
           </a:p>
           <a:p>
@@ -5324,7 +5347,7 @@
               </a:defRPr>
             </a:pPr>
             <a:r>
-              <a:t>  In the demonstration test script, the CSP receives eta and phi directly to evaluate modular match equations. Production pairing eliminates this requirement.</a:t>
+              <a:t>  Aggregated Schnorr NIZK verification is computed off-chain; on-chain RVSC enforces revocation non-membership and binding.</a:t>
             </a:r>
           </a:p>
           <a:p>
@@ -5405,7 +5428,7 @@
               </a:defRPr>
             </a:pPr>
             <a:r>
-              <a:t>  Local flag updates take &lt; 0.001 ms in memory; real Ethereum Sepolia block mining takes 21.83 s for deletion confirmation.</a:t>
+              <a:t>  Local flag updates take &lt; 0.001 ms in memory; real Ethereum Sepolia block mining takes 10.37 s for deletion confirmation.</a:t>
             </a:r>
           </a:p>
         </p:txBody>
@@ -5597,7 +5620,7 @@
               </a:defRPr>
             </a:pPr>
             <a:r>
-              <a:t>• 2. Demonstrated Empirical Speedup (12.11x): </a:t>
+              <a:t>• 2. Demonstrated Empirical Speedup: </a:t>
             </a:r>
           </a:p>
           <a:p>
@@ -5612,7 +5635,7 @@
               </a:defRPr>
             </a:pPr>
             <a:r>
-              <a:t>  SingleDocAdd runs in O(m) time (~0.67 ms at L=5,000), achieving a 12.11x speedup over Cheng et al. Section 5.10 index updates (and 3,527.7x over naive full re-encryption).</a:t>
+              <a:t>  SingleDocAdd runs in O(m) time (~0.34 ms full add at L=5,000), achieving a 5.27x pure index speedup and 5.46x full file add speedup over Cheng et al. Section 5.10 (724.0x over naive re-encryption).</a:t>
             </a:r>
           </a:p>
           <a:p>
@@ -5639,7 +5662,7 @@
               </a:defRPr>
             </a:pPr>
             <a:r>
-              <a:t>  Solidity deletedDocRegistry mapping executes in constant time via keccak256 slot calculation with zero array traversal.</a:t>
+              <a:t>  Solidity deletedDocRegistry mapping executes in constant time (50,111 EVM gas) with zero array traversal.</a:t>
             </a:r>
           </a:p>
           <a:p>
@@ -5666,7 +5689,7 @@
               </a:defRPr>
             </a:pPr>
             <a:r>
-              <a:t>  Smart contract deployed and verified on public Ethereum Sepolia Testnet (0xfDC8615Bf6483c3B0f39c330F55A56Cb0f08C8D3) with live mined transaction receipts.</a:t>
+              <a:t>  Smart contract deployed on public Ethereum Sepolia Testnet (0x17b09aad051BcD92EcfF3F08d87B1b333287cB1F) with verified runtime bytecode and live mined receipts.</a:t>
             </a:r>
           </a:p>
           <a:p>
@@ -6510,7 +6533,7 @@
               </a:defRPr>
             </a:pPr>
             <a:r>
-              <a:t>  Cheng et al. (Elsevier IoT, 2026) successfully established multi-authority ABE and blockchain result verification.</a:t>
+              <a:t>  Cheng et al. (Elsevier IoT, 2026) established multi-authority ABE and blockchain result verification.</a:t>
             </a:r>
           </a:p>
           <a:p>
@@ -6537,7 +6560,7 @@
               </a:defRPr>
             </a:pPr>
             <a:r>
-              <a:t>  Section 5.10 specifies index updates by multiplying X_upd across all L*m existing index entries (O(L*m)). Alternatively, full re-indexing requires re-encrypting all files.</a:t>
+              <a:t>  Section 5.10 specifies index updates by multiplying X_upd across all L*m existing index entries (O(L*m)). Full re-indexing requires re-encrypting all files.</a:t>
             </a:r>
           </a:p>
           <a:p>
@@ -6701,7 +6724,7 @@
               </a:defRPr>
             </a:pPr>
             <a:r>
-              <a:t>  Decouples the inverted keyword index so appending a record requires generating tokens only for its m keywords (~0.67 ms flat at L=5,000).</a:t>
+              <a:t>  Decouples inverted keyword index so appending a record requires generating tokens only for its m keywords (~0.34 ms full add at L=5,000).</a:t>
             </a:r>
           </a:p>
           <a:p>
@@ -6728,7 +6751,7 @@
               </a:defRPr>
             </a:pPr>
             <a:r>
-              <a:t>  Solidity hash mapping (deletedDocRegistry) executes constant-time revocation with zero array traversal.</a:t>
+              <a:t>  Solidity hash mapping (deletedDocRegistry) executes constant-time revocation (50,111 EVM gas; zero array traversal).</a:t>
             </a:r>
           </a:p>
           <a:p>
@@ -6755,7 +6778,7 @@
               </a:defRPr>
             </a:pPr>
             <a:r>
-              <a:t>  Evaluates speedup against both naive re-encryption and true Cheng et al. Section 5.10 index updates across 30 runs.</a:t>
+              <a:t>  Evaluates speedup against both naive re-encryption and true Cheng et al. Section 5.10 index updates across 30 runs with warm-up discarded.</a:t>
             </a:r>
           </a:p>
           <a:p>
@@ -6782,7 +6805,7 @@
               </a:defRPr>
             </a:pPr>
             <a:r>
-              <a:t>  Smart contract deployed and verified on Ethereum Sepolia Testnet with real transaction receipts.</a:t>
+              <a:t>  Smart contract deployed on Ethereum Sepolia Testnet with verified runtime bytecode and real transaction receipts.</a:t>
             </a:r>
           </a:p>
         </p:txBody>
@@ -7564,7 +7587,7 @@
               </a:defRPr>
             </a:pPr>
             <a:r>
-              <a:t>  Iterating arrays on-chain scales linearly (O(N) gas), risking transaction failure as N expands.</a:t>
+              <a:t>  Iterating arrays on-chain scales linearly (O(N) gas), risking transaction exhaustion as N expands.</a:t>
             </a:r>
           </a:p>
           <a:p>
@@ -7951,7 +7974,7 @@
               </a:defRPr>
             </a:pPr>
             <a:r>
-              <a:t>• Schnorr NIZK Aggregation:</a:t>
+              <a:t>• Off-Chain Proof &amp; On-Chain RVSC:</a:t>
             </a:r>
           </a:p>
           <a:p>
@@ -7966,7 +7989,7 @@
               </a:defRPr>
             </a:pPr>
             <a:r>
-              <a:t>  Off-chain proof (R, pi_hat) guarantees search correctness without exposing clinician attributes.</a:t>
+              <a:t>  Aggregated Schnorr NIZK proof (R, pi_hat) verified off-chain; on-chain RVSC verifies revocation non-membership.</a:t>
             </a:r>
           </a:p>
         </p:txBody>
@@ -8425,10 +8448,10 @@
               </a:tblPr>
               <a:tblGrid>
                 <a:gridCol w="914400"/>
-                <a:gridCol w="1097280"/>
-                <a:gridCol w="1097280"/>
+                <a:gridCol w="1005840"/>
+                <a:gridCol w="1005840"/>
+                <a:gridCol w="1005840"/>
                 <a:gridCol w="914400"/>
-                <a:gridCol w="822960"/>
               </a:tblGrid>
               <a:tr h="548640">
                 <a:tc>
@@ -8493,7 +8516,7 @@
                         </a:defRPr>
                       </a:pPr>
                       <a:r>
-                        <a:t>Cheng et al. [1]</a:t>
+                        <a:t>Cheng Idx [1]</a:t>
                       </a:r>
                     </a:p>
                   </a:txBody>
@@ -8517,7 +8540,7 @@
                         </a:defRPr>
                       </a:pPr>
                       <a:r>
-                        <a:t>BAMKS-D</a:t>
+                        <a:t>BAMKS-D Full</a:t>
                       </a:r>
                     </a:p>
                   </a:txBody>
@@ -8591,7 +8614,7 @@
                         </a:defRPr>
                       </a:pPr>
                       <a:r>
-                        <a:t>20.31 ms</a:t>
+                        <a:t>2.26 ms</a:t>
                       </a:r>
                     </a:p>
                   </a:txBody>
@@ -8615,7 +8638,7 @@
                         </a:defRPr>
                       </a:pPr>
                       <a:r>
-                        <a:t>0.084 ms</a:t>
+                        <a:t>0.015 ms</a:t>
                       </a:r>
                     </a:p>
                   </a:txBody>
@@ -8639,7 +8662,7 @@
                         </a:defRPr>
                       </a:pPr>
                       <a:r>
-                        <a:t>0.409 ms</a:t>
+                        <a:t>0.267 ms</a:t>
                       </a:r>
                     </a:p>
                   </a:txBody>
@@ -8663,7 +8686,7 @@
                         </a:defRPr>
                       </a:pPr>
                       <a:r>
-                        <a:t>0.21x</a:t>
+                        <a:t>0.06x</a:t>
                       </a:r>
                     </a:p>
                   </a:txBody>
@@ -8713,7 +8736,7 @@
                         </a:defRPr>
                       </a:pPr>
                       <a:r>
-                        <a:t>42.89 ms</a:t>
+                        <a:t>4.66 ms</a:t>
                       </a:r>
                     </a:p>
                   </a:txBody>
@@ -8737,7 +8760,7 @@
                         </a:defRPr>
                       </a:pPr>
                       <a:r>
-                        <a:t>0.164 ms</a:t>
+                        <a:t>0.032 ms</a:t>
                       </a:r>
                     </a:p>
                   </a:txBody>
@@ -8761,7 +8784,7 @@
                         </a:defRPr>
                       </a:pPr>
                       <a:r>
-                        <a:t>0.447 ms</a:t>
+                        <a:t>0.265 ms</a:t>
                       </a:r>
                     </a:p>
                   </a:txBody>
@@ -8785,7 +8808,7 @@
                         </a:defRPr>
                       </a:pPr>
                       <a:r>
-                        <a:t>0.37x</a:t>
+                        <a:t>0.12x</a:t>
                       </a:r>
                     </a:p>
                   </a:txBody>
@@ -8835,7 +8858,7 @@
                         </a:defRPr>
                       </a:pPr>
                       <a:r>
-                        <a:t>228.79 ms</a:t>
+                        <a:t>24.49 ms</a:t>
                       </a:r>
                     </a:p>
                   </a:txBody>
@@ -8859,7 +8882,7 @@
                         </a:defRPr>
                       </a:pPr>
                       <a:r>
-                        <a:t>0.816 ms</a:t>
+                        <a:t>0.183 ms</a:t>
                       </a:r>
                     </a:p>
                   </a:txBody>
@@ -8883,7 +8906,7 @@
                         </a:defRPr>
                       </a:pPr>
                       <a:r>
-                        <a:t>0.533 ms</a:t>
+                        <a:t>0.314 ms</a:t>
                       </a:r>
                     </a:p>
                   </a:txBody>
@@ -8907,7 +8930,7 @@
                         </a:defRPr>
                       </a:pPr>
                       <a:r>
-                        <a:t>1.53x</a:t>
+                        <a:t>0.58x</a:t>
                       </a:r>
                     </a:p>
                   </a:txBody>
@@ -8957,7 +8980,7 @@
                         </a:defRPr>
                       </a:pPr>
                       <a:r>
-                        <a:t>467.08 ms</a:t>
+                        <a:t>45.60 ms</a:t>
                       </a:r>
                     </a:p>
                   </a:txBody>
@@ -8981,7 +9004,7 @@
                         </a:defRPr>
                       </a:pPr>
                       <a:r>
-                        <a:t>1.559 ms</a:t>
+                        <a:t>0.325 ms</a:t>
                       </a:r>
                     </a:p>
                   </a:txBody>
@@ -9005,7 +9028,7 @@
                         </a:defRPr>
                       </a:pPr>
                       <a:r>
-                        <a:t>0.486 ms</a:t>
+                        <a:t>0.283 ms</a:t>
                       </a:r>
                     </a:p>
                   </a:txBody>
@@ -9029,7 +9052,7 @@
                         </a:defRPr>
                       </a:pPr>
                       <a:r>
-                        <a:t>3.20x</a:t>
+                        <a:t>1.15x</a:t>
                       </a:r>
                     </a:p>
                   </a:txBody>
@@ -9079,7 +9102,7 @@
                         </a:defRPr>
                       </a:pPr>
                       <a:r>
-                        <a:t>2,363.01 ms</a:t>
+                        <a:t>243.64 ms</a:t>
                       </a:r>
                     </a:p>
                   </a:txBody>
@@ -9103,7 +9126,7 @@
                         </a:defRPr>
                       </a:pPr>
                       <a:r>
-                        <a:t>8.112 ms</a:t>
+                        <a:t>1.772 ms</a:t>
                       </a:r>
                     </a:p>
                   </a:txBody>
@@ -9127,7 +9150,7 @@
                         </a:defRPr>
                       </a:pPr>
                       <a:r>
-                        <a:t>0.670 ms</a:t>
+                        <a:t>0.337 ms</a:t>
                       </a:r>
                     </a:p>
                   </a:txBody>
@@ -9151,7 +9174,7 @@
                         </a:defRPr>
                       </a:pPr>
                       <a:r>
-                        <a:t>12.11x</a:t>
+                        <a:t>5.27x / 5.46x</a:t>
                       </a:r>
                     </a:p>
                   </a:txBody>
@@ -9241,7 +9264,7 @@
               </a:defRPr>
             </a:pPr>
             <a:r>
-              <a:t>HONEST BENCHMARK ANALYSIS (m=3, 30 Runs, Intel i5-13420H):</a:t>
+              <a:t>BENCHMARK ANALYSIS (m=3, 30 Runs, Warm-up Discarded):</a:t>
             </a:r>
           </a:p>
           <a:p>
@@ -9253,15 +9276,15 @@
               </a:defRPr>
             </a:pPr>
             <a:r>
-              <a:t>• For L &lt;= 100, Cheng et al. index multiplication is faster than single-file AES encryption.</a:t>
+              <a:t>• For L &lt;= 500, Cheng et al. index multiplication is faster than BAMKS-D file encryption overhead.</a:t>
             </a:r>
             <a:br/>
             <a:r>
-              <a:t>• Break-even crossover occurs at L in [300, 410] files (L ~ 300 via local interpolation, L ~ 410 asymptotically against L=5,000).</a:t>
+              <a:t>• Crossover points: Pure Index Update at L ~ 800 files; Like-for-Like Full File Addition at L ~ 600 files.</a:t>
             </a:r>
             <a:br/>
             <a:r>
-              <a:t>• At L=5,000, BAMKS-D achieves 12.11x speedup over Cheng et al. (and 3,527.7x over naive re-encryption).</a:t>
+              <a:t>• At L=5,000: BAMKS-D achieves 5.27x pure index speedup, 5.46x full file add speedup, and 724.0x vs naive.</a:t>
             </a:r>
           </a:p>
         </p:txBody>

</xml_diff>